<commit_message>
Add optional official web notices and fix colloquial place lookup and dark contrast
</commit_message>
<xml_diff>
--- a/submission/GeoLens.pptx
+++ b/submission/GeoLens.pptx
@@ -1458,7 +1458,7 @@
                   <a:srgbClr val="566D72"/>
                 </a:solidFill>
               </a:rPr>
-              <a:t>LOCAL PROTOTYPE  |  23 OCT 2026</a:t>
+              <a:t>PUBLIC CORE  |  23 OCT 2026</a:t>
             </a:r>
             <a:endParaRPr lang="en-US" sz="900" dirty="0"/>
           </a:p>
@@ -1536,7 +1536,7 @@
                   <a:srgbClr val="142D38"/>
                 </a:solidFill>
               </a:rPr>
-              <a:t>Ten activities. English and Hindi. One local open-weights SLM.</a:t>
+              <a:t>Ten activities. English and Hindi. One open-weights SLM.</a:t>
             </a:r>
             <a:endParaRPr lang="en-US" sz="2300" dirty="0"/>
           </a:p>
@@ -1772,7 +1772,7 @@
                   <a:srgbClr val="566D72"/>
                 </a:solidFill>
               </a:rPr>
-              <a:t>LOCAL PROTOTYPE  |  23 OCT 2026</a:t>
+              <a:t>PUBLIC CORE  |  23 OCT 2026</a:t>
             </a:r>
             <a:endParaRPr lang="en-US" sz="900" dirty="0"/>
           </a:p>
@@ -2090,7 +2090,7 @@
                   <a:srgbClr val="566D72"/>
                 </a:solidFill>
               </a:rPr>
-              <a:t>LOCAL PROTOTYPE  |  23 OCT 2026</a:t>
+              <a:t>PUBLIC CORE  |  23 OCT 2026</a:t>
             </a:r>
             <a:endParaRPr lang="en-US" sz="900" dirty="0"/>
           </a:p>
@@ -2128,7 +2128,7 @@
                   <a:srgbClr val="142D38"/>
                 </a:solidFill>
               </a:rPr>
-              <a:t>Question → local SLM interpretation</a:t>
+              <a:t>Question → Qwen SLM interpretation</a:t>
             </a:r>
             <a:endParaRPr lang="en-US" sz="2400" dirty="0"/>
           </a:p>
@@ -2374,7 +2374,7 @@
                   <a:srgbClr val="566D72"/>
                 </a:solidFill>
               </a:rPr>
-              <a:t>LOCAL PROTOTYPE  |  23 OCT 2026</a:t>
+              <a:t>PUBLIC CORE  |  23 OCT 2026</a:t>
             </a:r>
             <a:endParaRPr lang="en-US" sz="900" dirty="0"/>
           </a:p>
@@ -2426,7 +2426,7 @@
                   <a:srgbClr val="142D38"/>
                 </a:solidFill>
               </a:rPr>
-              <a:t>2,274,069,824 parameters in the full original release.</a:t>
+              <a:t>2,213,241,664 parameters loaded by the inference class.</a:t>
             </a:r>
             <a:endParaRPr lang="en-US" sz="2200" dirty="0"/>
           </a:p>
@@ -2480,7 +2480,7 @@
                   <a:srgbClr val="142D38"/>
                 </a:solidFill>
               </a:rPr>
-              <a:t>Pinned Q4_K_M runtime, 2 CPU threads, 2K context, thinking off.</a:t>
+              <a:t>One existing Modal endpoint in production; local CPU runtime for development.</a:t>
             </a:r>
             <a:endParaRPr lang="en-US" sz="2200" dirty="0"/>
           </a:p>
@@ -2494,7 +2494,7 @@
                   <a:srgbClr val="142D38"/>
                 </a:solidFill>
               </a:rPr>
-              <a:t>Original-format weights, tokenizer, config and licence staged locally.</a:t>
+              <a:t>Public checkpoint: huggingface.co/manavmodi/geolens-geoai-2026</a:t>
             </a:r>
             <a:endParaRPr lang="en-US" sz="2200" dirty="0"/>
           </a:p>
@@ -2508,7 +2508,7 @@
                   <a:srgbClr val="142D38"/>
                 </a:solidFill>
               </a:rPr>
-              <a:t>Public Hugging Face publication and clean public load remain release gates.</a:t>
+              <a:t>Public-ID load and generation passed with SHA-verified cached weights.</a:t>
             </a:r>
             <a:endParaRPr lang="en-US" sz="2200" dirty="0"/>
           </a:p>
@@ -2648,7 +2648,7 @@
                   <a:srgbClr val="142D38"/>
                 </a:solidFill>
               </a:rPr>
-              <a:t>Measured on the local machine</a:t>
+              <a:t>Measured behavior and resource limits</a:t>
             </a:r>
             <a:endParaRPr lang="en-US" sz="3200" dirty="0"/>
           </a:p>
@@ -2684,7 +2684,7 @@
                   <a:srgbClr val="566D72"/>
                 </a:solidFill>
               </a:rPr>
-              <a:t>LOCAL PROTOTYPE  |  23 OCT 2026</a:t>
+              <a:t>PUBLIC CORE  |  23 OCT 2026</a:t>
             </a:r>
             <a:endParaRPr lang="en-US" sz="900" dirty="0"/>
           </a:p>
@@ -2717,76 +2717,104 @@
               <a:buNone/>
             </a:pPr>
             <a:r>
-              <a:rPr lang="en-US" sz="2300" dirty="0">
-                <a:solidFill>
-                  <a:srgbClr val="142D38"/>
-                </a:solidFill>
-              </a:rPr>
-              <a:t>71 correctness tests pass across all ten activity profiles.</a:t>
-            </a:r>
-            <a:endParaRPr lang="en-US" sz="2300" dirty="0"/>
-          </a:p>
-          <a:p>
-            <a:pPr indent="0" marL="0">
-              <a:buNone/>
-            </a:pPr>
-            <a:r>
-              <a:rPr lang="en-US" sz="2300" dirty="0">
-                <a:solidFill>
-                  <a:srgbClr val="142D38"/>
-                </a:solidFill>
-              </a:rPr>
-              <a:t>Two concurrent requests: 8.2–9.2 seconds, both HTTP 200.</a:t>
-            </a:r>
-            <a:endParaRPr lang="en-US" sz="2300" dirty="0"/>
-          </a:p>
-          <a:p>
-            <a:pPr indent="0" marL="0">
-              <a:buNone/>
-            </a:pPr>
-            <a:r>
-              <a:rPr lang="en-US" sz="2300" dirty="0">
-                <a:solidFill>
-                  <a:srgbClr val="142D38"/>
-                </a:solidFill>
-              </a:rPr>
-              <a:t>Five concurrent requests: 17.3–21.0 seconds, all HTTP 200.</a:t>
-            </a:r>
-            <a:endParaRPr lang="en-US" sz="2300" dirty="0"/>
-          </a:p>
-          <a:p>
-            <a:pPr indent="0" marL="0">
-              <a:buNone/>
-            </a:pPr>
-            <a:r>
-              <a:rPr lang="en-US" sz="2300" dirty="0">
-                <a:solidFill>
-                  <a:srgbClr val="142D38"/>
-                </a:solidFill>
-              </a:rPr>
-              <a:t>Observed model working set: about 1.5–2.0 GiB in these runs.</a:t>
-            </a:r>
-            <a:endParaRPr lang="en-US" sz="2300" dirty="0"/>
-          </a:p>
-          <a:p>
-            <a:pPr indent="0" marL="0">
-              <a:buNone/>
-            </a:pPr>
-            <a:endParaRPr lang="en-US" sz="2300" dirty="0"/>
-          </a:p>
-          <a:p>
-            <a:pPr indent="0" marL="0">
-              <a:buNone/>
-            </a:pPr>
-            <a:r>
-              <a:rPr lang="en-US" sz="2300" dirty="0">
-                <a:solidFill>
-                  <a:srgbClr val="142D38"/>
-                </a:solidFill>
-              </a:rPr>
-              <a:t>Ryzen AI 9 HX 370, Windows, 2 inference threads. These small samples do not establish p95 or production capacity. Linux container limits require deployment verification.</a:t>
-            </a:r>
-            <a:endParaRPr lang="en-US" sz="2300" dirty="0"/>
+              <a:rPr lang="en-US" sz="2200" dirty="0">
+                <a:solidFill>
+                  <a:srgbClr val="142D38"/>
+                </a:solidFill>
+              </a:rPr>
+              <a:t>82 local correctness tests pass; frontend production build passes.</a:t>
+            </a:r>
+            <a:endParaRPr lang="en-US" sz="2200" dirty="0"/>
+          </a:p>
+          <a:p>
+            <a:pPr indent="0" marL="0">
+              <a:buNone/>
+            </a:pPr>
+            <a:r>
+              <a:rPr lang="en-US" sz="2200" dirty="0">
+                <a:solidFill>
+                  <a:srgbClr val="142D38"/>
+                </a:solidFill>
+              </a:rPr>
+              <a:t>All ten activities: public Bengaluru queries returned HTTP 200.</a:t>
+            </a:r>
+            <a:endParaRPr lang="en-US" sz="2200" dirty="0"/>
+          </a:p>
+          <a:p>
+            <a:pPr indent="0" marL="0">
+              <a:buNone/>
+            </a:pPr>
+            <a:r>
+              <a:rPr lang="en-US" sz="2200" dirty="0">
+                <a:solidFill>
+                  <a:srgbClr val="142D38"/>
+                </a:solidFill>
+              </a:rPr>
+              <a:t>Warm complete public queries: 1.8–6.3 seconds in this small sample.</a:t>
+            </a:r>
+            <a:endParaRPr lang="en-US" sz="2200" dirty="0"/>
+          </a:p>
+          <a:p>
+            <a:pPr indent="0" marL="0">
+              <a:buNone/>
+            </a:pPr>
+            <a:r>
+              <a:rPr lang="en-US" sz="2200" dirty="0">
+                <a:solidFill>
+                  <a:srgbClr val="142D38"/>
+                </a:solidFill>
+              </a:rPr>
+              <a:t>Cold model response: 57.5 s. Warm Hindi interpretation: 1.1 s.</a:t>
+            </a:r>
+            <a:endParaRPr lang="en-US" sz="2200" dirty="0"/>
+          </a:p>
+          <a:p>
+            <a:pPr indent="0" marL="0">
+              <a:buNone/>
+            </a:pPr>
+            <a:r>
+              <a:rPr lang="en-US" sz="2200" dirty="0">
+                <a:solidFill>
+                  <a:srgbClr val="142D38"/>
+                </a:solidFill>
+              </a:rPr>
+              <a:t>VPS API: 198 MiB observed; capped at 512 MiB / 0.4 CPU.</a:t>
+            </a:r>
+            <a:endParaRPr lang="en-US" sz="2200" dirty="0"/>
+          </a:p>
+          <a:p>
+            <a:pPr indent="0" marL="0">
+              <a:buNone/>
+            </a:pPr>
+            <a:endParaRPr lang="en-US" sz="2200" dirty="0"/>
+          </a:p>
+          <a:p>
+            <a:pPr indent="0" marL="0">
+              <a:buNone/>
+            </a:pPr>
+            <a:r>
+              <a:rPr lang="en-US" sz="2200" dirty="0">
+                <a:solidFill>
+                  <a:srgbClr val="142D38"/>
+                </a:solidFill>
+              </a:rPr>
+              <a:t>Samples do not establish p95. First generated token was not measured.</a:t>
+            </a:r>
+            <a:endParaRPr lang="en-US" sz="2200" dirty="0"/>
+          </a:p>
+          <a:p>
+            <a:pPr indent="0" marL="0">
+              <a:buNone/>
+            </a:pPr>
+            <a:r>
+              <a:rPr lang="en-US" sz="2200" dirty="0">
+                <a:solidFill>
+                  <a:srgbClr val="142D38"/>
+                </a:solidFill>
+              </a:rPr>
+              <a:t>Modal: zero minimum replicas, one maximum, 300-second idle delay.</a:t>
+            </a:r>
+            <a:endParaRPr lang="en-US" sz="2200" dirty="0"/>
           </a:p>
         </p:txBody>
       </p:sp>
@@ -2924,7 +2952,7 @@
                   <a:srgbClr val="142D38"/>
                 </a:solidFill>
               </a:rPr>
-              <a:t>Release gates and scientific limits</a:t>
+              <a:t>Public release and scientific limits</a:t>
             </a:r>
             <a:endParaRPr lang="en-US" sz="3200" dirty="0"/>
           </a:p>
@@ -2960,7 +2988,7 @@
                   <a:srgbClr val="566D72"/>
                 </a:solidFill>
               </a:rPr>
-              <a:t>LOCAL PROTOTYPE  |  23 OCT 2026</a:t>
+              <a:t>PUBLIC CORE  |  23 OCT 2026</a:t>
             </a:r>
             <a:endParaRPr lang="en-US" sz="900" dirty="0"/>
           </a:p>
@@ -2998,7 +3026,7 @@
                   <a:srgbClr val="142D38"/>
                 </a:solidFill>
               </a:rPr>
-              <a:t>Ready locally: API, website, model inference, genuine data fallback, tests and reproducibility files.</a:t>
+              <a:t>Website / API: geo.setuconsultants.in</a:t>
             </a:r>
             <a:endParaRPr lang="en-US" sz="2200" dirty="0"/>
           </a:p>
@@ -3006,6 +3034,14 @@
             <a:pPr indent="0" marL="0">
               <a:buNone/>
             </a:pPr>
+            <a:r>
+              <a:rPr lang="en-US" sz="2200" dirty="0">
+                <a:solidFill>
+                  <a:srgbClr val="142D38"/>
+                </a:solidFill>
+              </a:rPr>
+              <a:t>Code: github.com/stupiduck/geolens-geoai-2026</a:t>
+            </a:r>
             <a:endParaRPr lang="en-US" sz="2200" dirty="0"/>
           </a:p>
           <a:p>
@@ -3018,7 +3054,7 @@
                   <a:srgbClr val="142D38"/>
                 </a:solidFill>
               </a:rPr>
-              <a:t>Still required: chosen public GitHub/HF identities, successful public model load, authorized isolated deployment, externally verified API and judging-window uptime.</a:t>
+              <a:t>Model: huggingface.co/manavmodi/geolens-geoai-2026</a:t>
             </a:r>
             <a:endParaRPr lang="en-US" sz="2200" dirty="0"/>
           </a:p>
@@ -3058,7 +3094,21 @@
                   <a:srgbClr val="142D38"/>
                 </a:solidFill>
               </a:rPr>
-              <a:t>AI coding disclosure: OpenAI Codex. No sub-agents. No paid/private runtime inference or data API.</a:t>
+              <a:t>Optional Tavily notices and contrast updates are local/source-only for review. Screens shown are genuine local captures.</a:t>
+            </a:r>
+            <a:endParaRPr lang="en-US" sz="2200" dirty="0"/>
+          </a:p>
+          <a:p>
+            <a:pPr indent="0" marL="0">
+              <a:buNone/>
+            </a:pPr>
+            <a:r>
+              <a:rPr lang="en-US" sz="2200" dirty="0">
+                <a:solidFill>
+                  <a:srgbClr val="142D38"/>
+                </a:solidFill>
+              </a:rPr>
+              <a:t>Coding AI: OpenAI Codex. No sub-agents.</a:t>
             </a:r>
             <a:endParaRPr lang="en-US" sz="2200" dirty="0"/>
           </a:p>

</xml_diff>